<commit_message>
Fix SRC-048 date check, label rounded vs unrounded mid-point, IM footer, slide 12 sourcing
Co-Authored-By: Claude Sonnet 5.5 <noreply@anthropic.com>
</commit_message>
<xml_diff>
--- a/11_Post_Announcement_v2/Project_Southeast_Asia_v2_Transaction_Review.pptx
+++ b/11_Post_Announcement_v2/Project_Southeast_Asia_v2_Transaction_Review.pptx
@@ -603,7 +603,7 @@
                   <c:v>September recommended mid-point</c:v>
                 </c:pt>
                 <c:pt idx="1">
-                  <c:v>v2 weighted mid-point</c:v>
+                  <c:v>v2 weighted mid-point (rounded to 25)</c:v>
                 </c:pt>
                 <c:pt idx="2">
                   <c:v>Announced EV</c:v>
@@ -1676,7 +1676,7 @@
                   <c:v>Precedents EV/Revenue</c:v>
                 </c:pt>
                 <c:pt idx="7">
-                  <c:v>Weighted blend</c:v>
+                  <c:v>Weighted blend (unrounded)</c:v>
                 </c:pt>
               </c:strCache>
             </c:strRef>
@@ -7546,7 +7546,7 @@
                 </a:solidFill>
                 <a:latin typeface="Cambria"/>
               </a:rPr>
-              <a:t>Several buyer entities take different countries, so closing risk is staged rather than single</a:t>
+              <a:t>Reported structure: several Nippon Paint entities take different countries, so closing risk is staged</a:t>
             </a:r>
           </a:p>
         </p:txBody>
@@ -8632,7 +8632,7 @@
                 </a:solidFill>
                 <a:latin typeface="Calibri"/>
               </a:rPr>
-              <a:t>No view is given on why the structure was chosen. Transfers in Thailand, Australia and Papua New Guinea cover receivables, inventory and other assets and liabilities (REPORTED, SRC-042).</a:t>
+              <a:t>No view is given on why the structure was chosen. Transfers in Thailand, Australia and Papua New Guinea cover receivables, inventory and other assets and liabilities (REPORTED, SRC-042; single source: Yahoo Finance Singapore / MT Newswires).</a:t>
             </a:r>
           </a:p>
         </p:txBody>
@@ -12560,7 +12560,7 @@
                 </a:solidFill>
                 <a:latin typeface="Calibri"/>
               </a:rPr>
-              <a:t>Weighted range EUR 550 / 775 / 1,100m (low / mid / high), set before the comparison with the price.</a:t>
+              <a:t>Weighted range, rounded to 25: EUR 550 / 775 / 1,100m (low / mid / high), set before the comparison with the price. The bar shows the unrounded blend.</a:t>
             </a:r>
           </a:p>
           <a:p>

</xml_diff>